<commit_message>
Slides: show the transformers MLP code for write vectors instead of a formula
Co-Authored-By: Claude Opus 5.5 <noreply@anthropic.com>
</commit_message>
<xml_diff>
--- a/slides/refusal_neurons_update.pptx
+++ b/slides/refusal_neurons_update.pptx
@@ -4266,7 +4266,7 @@
           <a:p>
             <a:r>
               <a:rPr lang="en-US" dirty="0"/>
-              <a:t>The shrink step of the MLP block turns the 12,288 neuron values back into 4,096 numbers. Mathematically it is a sum: MLP output = h1 times v1 plus h2 times v2 and so on up to h12288 times v12288. h is the neuron's value, which changes with the prompt. v is a fixed list of 4,096 numbers learned in training: one column of the shrink matrix, called down_proj in the code. So when a neuron fires, it adds its own fixed arrow v to the residual stream, scaled by how strongly it fires. That arrow is the neuron's write vector: the direction it pushes the residual stream in. A refusal direction also lives in the residual stream, so we can ask whether a neuron's arrow points the same way as the refusal direction.</a:t>
+              <a:t>Left: the MLP block exactly as it is written in Hugging Face transformers for Qwen3. gate_proj and up_proj expand the 4,096 numbers to 12,288; act_fn is the squash; down_proj shrinks back to 4,096. The thing passed into down_proj is the 12,288 neurons, h. Right: what we do with it. We hook the input of down_proj to read the neurons or pin one. Neuron 7924's write vector is column 7924 of down_proj's weight matrix: 4,096 fixed numbers learned in training. down_proj multiplies that matrix by h, which is the same as adding up h[i] times column i over all 12,288 neurons. So neuron 7924 adds h[7924] times its own fixed column to the residual stream: its write vector, scaled by how strongly it fires.</a:t>
             </a:r>
             <a:endParaRPr lang="en-US" dirty="0"/>
           </a:p>
@@ -21982,8 +21982,8 @@
         </p:nvSpPr>
         <p:spPr>
           <a:xfrm>
-            <a:off x="548640" y="1600200"/>
-            <a:ext cx="11094415" cy="731520"/>
+            <a:off x="548640" y="1417320"/>
+            <a:ext cx="5989320" cy="274320"/>
           </a:xfrm>
           <a:prstGeom prst="rect">
             <a:avLst/>
@@ -21995,21 +21995,21 @@
           <a:bodyPr wrap="square" lIns="0" tIns="0" rIns="0" bIns="0" rtlCol="0" anchor="ctr"/>
           <a:lstStyle/>
           <a:p>
-            <a:pPr algn="ctr" indent="0" marL="0">
-              <a:buNone/>
-            </a:pPr>
-            <a:r>
-              <a:rPr lang="en-US" sz="2800" b="1" dirty="0">
-                <a:solidFill>
-                  <a:srgbClr val="1F2328"/>
-                </a:solidFill>
-                <a:latin typeface="Arial" pitchFamily="34" charset="0"/>
-                <a:ea typeface="Arial" pitchFamily="34" charset="-122"/>
-                <a:cs typeface="Arial" pitchFamily="34" charset="-120"/>
-              </a:rPr>
-              <a:t>MLP output  =  h₁·v₁  +  h₂·v₂  +  …  +  h₁₂₂₈₈·v₁₂₂₈₈</a:t>
-            </a:r>
-            <a:endParaRPr lang="en-US" sz="2800" dirty="0"/>
+            <a:pPr indent="0" marL="0">
+              <a:buNone/>
+            </a:pPr>
+            <a:r>
+              <a:rPr lang="en-US" sz="1200" b="1" spc="100" kern="0" dirty="0">
+                <a:solidFill>
+                  <a:srgbClr val="5F6B7A"/>
+                </a:solidFill>
+                <a:latin typeface="Arial" pitchFamily="34" charset="0"/>
+                <a:ea typeface="Arial" pitchFamily="34" charset="-122"/>
+                <a:cs typeface="Arial" pitchFamily="34" charset="-120"/>
+              </a:rPr>
+              <a:t>TRANSFORMERS LIBRARY, QWEN3 (8B SIZES FILLED IN)</a:t>
+            </a:r>
+            <a:endParaRPr lang="en-US" sz="1200" dirty="0"/>
           </a:p>
         </p:txBody>
       </p:sp>
@@ -22021,20 +22021,20 @@
         </p:nvSpPr>
         <p:spPr>
           <a:xfrm>
-            <a:off x="548640" y="2651760"/>
-            <a:ext cx="5394960" cy="1737360"/>
+            <a:off x="548640" y="1737360"/>
+            <a:ext cx="5989320" cy="3246120"/>
           </a:xfrm>
           <a:prstGeom prst="roundRect">
             <a:avLst>
-              <a:gd name="adj" fmla="val 4211"/>
+              <a:gd name="adj" fmla="val 1690"/>
             </a:avLst>
           </a:prstGeom>
           <a:solidFill>
-            <a:srgbClr val="F4F6F9"/>
+            <a:srgbClr val="1E2329"/>
           </a:solidFill>
           <a:ln w="12700">
             <a:solidFill>
-              <a:srgbClr val="D8DEE6"/>
+              <a:srgbClr val="1E2329"/>
             </a:solidFill>
             <a:prstDash val="solid"/>
           </a:ln>
@@ -22048,8 +22048,8 @@
         </p:nvSpPr>
         <p:spPr>
           <a:xfrm>
-            <a:off x="777240" y="2743200"/>
-            <a:ext cx="4937760" cy="411480"/>
+            <a:off x="731520" y="1828800"/>
+            <a:ext cx="5669280" cy="3063240"/>
           </a:xfrm>
           <a:prstGeom prst="rect">
             <a:avLst/>
@@ -22058,24 +22058,236 @@
           <a:ln/>
         </p:spPr>
         <p:txBody>
-          <a:bodyPr wrap="square" lIns="0" tIns="0" rIns="0" bIns="0" rtlCol="0" anchor="ctr"/>
+          <a:bodyPr wrap="square" lIns="0" tIns="0" rIns="0" bIns="0" rtlCol="0" anchor="t"/>
           <a:lstStyle/>
           <a:p>
             <a:pPr indent="0" marL="0">
-              <a:buNone/>
-            </a:pPr>
-            <a:r>
-              <a:rPr lang="en-US" sz="1800" b="1" dirty="0">
-                <a:solidFill>
-                  <a:srgbClr val="1F2328"/>
-                </a:solidFill>
-                <a:latin typeface="Arial" pitchFamily="34" charset="0"/>
-                <a:ea typeface="Arial" pitchFamily="34" charset="-122"/>
-                <a:cs typeface="Arial" pitchFamily="34" charset="-120"/>
-              </a:rPr>
-              <a:t>h = the neuron's value</a:t>
-            </a:r>
-            <a:endParaRPr lang="en-US" sz="1800" dirty="0"/>
+              <a:spcAft>
+                <a:spcPts val="300"/>
+              </a:spcAft>
+              <a:buNone/>
+            </a:pPr>
+            <a:r>
+              <a:rPr lang="en-US" sz="1200" dirty="0">
+                <a:solidFill>
+                  <a:srgbClr val="E6EDF3"/>
+                </a:solidFill>
+                <a:latin typeface="Courier New" pitchFamily="34" charset="0"/>
+                <a:ea typeface="Courier New" pitchFamily="34" charset="-122"/>
+                <a:cs typeface="Courier New" pitchFamily="34" charset="-120"/>
+              </a:rPr>
+              <a:t>class Qwen3MLP(nn.Module):</a:t>
+            </a:r>
+            <a:endParaRPr lang="en-US" sz="1200" dirty="0"/>
+          </a:p>
+          <a:p>
+            <a:pPr indent="0" marL="0">
+              <a:spcAft>
+                <a:spcPts val="300"/>
+              </a:spcAft>
+              <a:buNone/>
+            </a:pPr>
+            <a:r>
+              <a:rPr lang="en-US" sz="1200" dirty="0">
+                <a:solidFill>
+                  <a:srgbClr val="E6EDF3"/>
+                </a:solidFill>
+                <a:latin typeface="Courier New" pitchFamily="34" charset="0"/>
+                <a:ea typeface="Courier New" pitchFamily="34" charset="-122"/>
+                <a:cs typeface="Courier New" pitchFamily="34" charset="-120"/>
+              </a:rPr>
+              <a:t>    def __init__(self, config):</a:t>
+            </a:r>
+            <a:endParaRPr lang="en-US" sz="1200" dirty="0"/>
+          </a:p>
+          <a:p>
+            <a:pPr indent="0" marL="0">
+              <a:spcAft>
+                <a:spcPts val="300"/>
+              </a:spcAft>
+              <a:buNone/>
+            </a:pPr>
+            <a:r>
+              <a:rPr lang="en-US" sz="1200" dirty="0">
+                <a:solidFill>
+                  <a:srgbClr val="E6EDF3"/>
+                </a:solidFill>
+                <a:latin typeface="Courier New" pitchFamily="34" charset="0"/>
+                <a:ea typeface="Courier New" pitchFamily="34" charset="-122"/>
+                <a:cs typeface="Courier New" pitchFamily="34" charset="-120"/>
+              </a:rPr>
+              <a:t>        self.gate_proj = nn.Linear(4096, 12288)  # expand</a:t>
+            </a:r>
+            <a:endParaRPr lang="en-US" sz="1200" dirty="0"/>
+          </a:p>
+          <a:p>
+            <a:pPr indent="0" marL="0">
+              <a:spcAft>
+                <a:spcPts val="300"/>
+              </a:spcAft>
+              <a:buNone/>
+            </a:pPr>
+            <a:r>
+              <a:rPr lang="en-US" sz="1200" dirty="0">
+                <a:solidFill>
+                  <a:srgbClr val="E6EDF3"/>
+                </a:solidFill>
+                <a:latin typeface="Courier New" pitchFamily="34" charset="0"/>
+                <a:ea typeface="Courier New" pitchFamily="34" charset="-122"/>
+                <a:cs typeface="Courier New" pitchFamily="34" charset="-120"/>
+              </a:rPr>
+              <a:t>        self.up_proj   = nn.Linear(4096, 12288)  # expand</a:t>
+            </a:r>
+            <a:endParaRPr lang="en-US" sz="1200" dirty="0"/>
+          </a:p>
+          <a:p>
+            <a:pPr indent="0" marL="0">
+              <a:spcAft>
+                <a:spcPts val="300"/>
+              </a:spcAft>
+              <a:buNone/>
+            </a:pPr>
+            <a:r>
+              <a:rPr lang="en-US" sz="1200" b="1" dirty="0">
+                <a:solidFill>
+                  <a:srgbClr val="F2A97F"/>
+                </a:solidFill>
+                <a:latin typeface="Courier New" pitchFamily="34" charset="0"/>
+                <a:ea typeface="Courier New" pitchFamily="34" charset="-122"/>
+                <a:cs typeface="Courier New" pitchFamily="34" charset="-120"/>
+              </a:rPr>
+              <a:t>        self.down_proj = nn.Linear(12288, 4096)  # shrink</a:t>
+            </a:r>
+            <a:endParaRPr lang="en-US" sz="1200" dirty="0"/>
+          </a:p>
+          <a:p>
+            <a:pPr indent="0" marL="0">
+              <a:spcAft>
+                <a:spcPts val="300"/>
+              </a:spcAft>
+              <a:buNone/>
+            </a:pPr>
+            <a:r>
+              <a:rPr lang="en-US" sz="1200" dirty="0">
+                <a:solidFill>
+                  <a:srgbClr val="E6EDF3"/>
+                </a:solidFill>
+                <a:latin typeface="Courier New" pitchFamily="34" charset="0"/>
+                <a:ea typeface="Courier New" pitchFamily="34" charset="-122"/>
+                <a:cs typeface="Courier New" pitchFamily="34" charset="-120"/>
+              </a:rPr>
+              <a:t>        self.act_fn    = SiLU                    # squash</a:t>
+            </a:r>
+            <a:endParaRPr lang="en-US" sz="1200" dirty="0"/>
+          </a:p>
+          <a:p>
+            <a:pPr indent="0" marL="0">
+              <a:spcAft>
+                <a:spcPts val="300"/>
+              </a:spcAft>
+              <a:buNone/>
+            </a:pPr>
+            <a:endParaRPr lang="en-US" sz="1200" dirty="0"/>
+          </a:p>
+          <a:p>
+            <a:pPr indent="0" marL="0">
+              <a:spcAft>
+                <a:spcPts val="300"/>
+              </a:spcAft>
+              <a:buNone/>
+            </a:pPr>
+            <a:r>
+              <a:rPr lang="en-US" sz="1200" dirty="0">
+                <a:solidFill>
+                  <a:srgbClr val="E6EDF3"/>
+                </a:solidFill>
+                <a:latin typeface="Courier New" pitchFamily="34" charset="0"/>
+                <a:ea typeface="Courier New" pitchFamily="34" charset="-122"/>
+                <a:cs typeface="Courier New" pitchFamily="34" charset="-120"/>
+              </a:rPr>
+              <a:t>    def forward(self, x):          # x = 4,096 numbers</a:t>
+            </a:r>
+            <a:endParaRPr lang="en-US" sz="1200" dirty="0"/>
+          </a:p>
+          <a:p>
+            <a:pPr indent="0" marL="0">
+              <a:spcAft>
+                <a:spcPts val="300"/>
+              </a:spcAft>
+              <a:buNone/>
+            </a:pPr>
+            <a:r>
+              <a:rPr lang="en-US" sz="1200" dirty="0">
+                <a:solidFill>
+                  <a:srgbClr val="E6EDF3"/>
+                </a:solidFill>
+                <a:latin typeface="Courier New" pitchFamily="34" charset="0"/>
+                <a:ea typeface="Courier New" pitchFamily="34" charset="-122"/>
+                <a:cs typeface="Courier New" pitchFamily="34" charset="-120"/>
+              </a:rPr>
+              <a:t>        down_proj = self.down_proj(</a:t>
+            </a:r>
+            <a:endParaRPr lang="en-US" sz="1200" dirty="0"/>
+          </a:p>
+          <a:p>
+            <a:pPr indent="0" marL="0">
+              <a:spcAft>
+                <a:spcPts val="300"/>
+              </a:spcAft>
+              <a:buNone/>
+            </a:pPr>
+            <a:r>
+              <a:rPr lang="en-US" sz="1200" b="1" dirty="0">
+                <a:solidFill>
+                  <a:srgbClr val="F2A97F"/>
+                </a:solidFill>
+                <a:latin typeface="Courier New" pitchFamily="34" charset="0"/>
+                <a:ea typeface="Courier New" pitchFamily="34" charset="-122"/>
+                <a:cs typeface="Courier New" pitchFamily="34" charset="-120"/>
+              </a:rPr>
+              <a:t>          self.act_fn(self.gate_proj(x)) * self.up_proj(x))</a:t>
+            </a:r>
+            <a:endParaRPr lang="en-US" sz="1200" dirty="0"/>
+          </a:p>
+          <a:p>
+            <a:pPr indent="0" marL="0">
+              <a:spcAft>
+                <a:spcPts val="300"/>
+              </a:spcAft>
+              <a:buNone/>
+            </a:pPr>
+            <a:r>
+              <a:rPr lang="en-US" sz="1200" dirty="0">
+                <a:solidFill>
+                  <a:srgbClr val="8B98A8"/>
+                </a:solidFill>
+                <a:latin typeface="Courier New" pitchFamily="34" charset="0"/>
+                <a:ea typeface="Courier New" pitchFamily="34" charset="-122"/>
+                <a:cs typeface="Courier New" pitchFamily="34" charset="-120"/>
+              </a:rPr>
+              <a:t>        #   ↑ this product = the 12,288 neurons (call it h)</a:t>
+            </a:r>
+            <a:endParaRPr lang="en-US" sz="1200" dirty="0"/>
+          </a:p>
+          <a:p>
+            <a:pPr indent="0" marL="0">
+              <a:spcAft>
+                <a:spcPts val="300"/>
+              </a:spcAft>
+              <a:buNone/>
+            </a:pPr>
+            <a:r>
+              <a:rPr lang="en-US" sz="1200" dirty="0">
+                <a:solidFill>
+                  <a:srgbClr val="E6EDF3"/>
+                </a:solidFill>
+                <a:latin typeface="Courier New" pitchFamily="34" charset="0"/>
+                <a:ea typeface="Courier New" pitchFamily="34" charset="-122"/>
+                <a:cs typeface="Courier New" pitchFamily="34" charset="-120"/>
+              </a:rPr>
+              <a:t>        return down_proj           # back to 4,096 numbers</a:t>
+            </a:r>
+            <a:endParaRPr lang="en-US" sz="1200" dirty="0"/>
           </a:p>
         </p:txBody>
       </p:sp>
@@ -22087,8 +22299,8 @@
         </p:nvSpPr>
         <p:spPr>
           <a:xfrm>
-            <a:off x="777240" y="3200400"/>
-            <a:ext cx="4937760" cy="1097280"/>
+            <a:off x="6720840" y="1417320"/>
+            <a:ext cx="4922215" cy="274320"/>
           </a:xfrm>
           <a:prstGeom prst="rect">
             <a:avLst/>
@@ -22097,24 +22309,24 @@
           <a:ln/>
         </p:spPr>
         <p:txBody>
-          <a:bodyPr wrap="square" lIns="0" tIns="0" rIns="0" bIns="0" rtlCol="0" anchor="t"/>
+          <a:bodyPr wrap="square" lIns="0" tIns="0" rIns="0" bIns="0" rtlCol="0" anchor="ctr"/>
           <a:lstStyle/>
           <a:p>
             <a:pPr indent="0" marL="0">
               <a:buNone/>
             </a:pPr>
             <a:r>
-              <a:rPr lang="en-US" sz="1500" dirty="0">
-                <a:solidFill>
-                  <a:srgbClr val="1F2328"/>
-                </a:solidFill>
-                <a:latin typeface="Arial" pitchFamily="34" charset="0"/>
-                <a:ea typeface="Arial" pitchFamily="34" charset="-122"/>
-                <a:cs typeface="Arial" pitchFamily="34" charset="-120"/>
-              </a:rPr>
-              <a:t>Changes with every prompt. For L14:F7924: about −4.4 on a harmful request, about 0 on a normal one.</a:t>
-            </a:r>
-            <a:endParaRPr lang="en-US" sz="1500" dirty="0"/>
+              <a:rPr lang="en-US" sz="1200" b="1" spc="100" kern="0" dirty="0">
+                <a:solidFill>
+                  <a:srgbClr val="5F6B7A"/>
+                </a:solidFill>
+                <a:latin typeface="Arial" pitchFamily="34" charset="0"/>
+                <a:ea typeface="Arial" pitchFamily="34" charset="-122"/>
+                <a:cs typeface="Arial" pitchFamily="34" charset="-120"/>
+              </a:rPr>
+              <a:t>WHAT WE DO WITH IT (OUR CODE)</a:t>
+            </a:r>
+            <a:endParaRPr lang="en-US" sz="1200" dirty="0"/>
           </a:p>
         </p:txBody>
       </p:sp>
@@ -22126,20 +22338,20 @@
         </p:nvSpPr>
         <p:spPr>
           <a:xfrm>
-            <a:off x="6245352" y="2651760"/>
-            <a:ext cx="5394960" cy="1737360"/>
+            <a:off x="6720840" y="1737360"/>
+            <a:ext cx="4922215" cy="3246120"/>
           </a:xfrm>
           <a:prstGeom prst="roundRect">
             <a:avLst>
-              <a:gd name="adj" fmla="val 4211"/>
+              <a:gd name="adj" fmla="val 1690"/>
             </a:avLst>
           </a:prstGeom>
           <a:solidFill>
-            <a:srgbClr val="F4F6F9"/>
+            <a:srgbClr val="1E2329"/>
           </a:solidFill>
           <a:ln w="12700">
             <a:solidFill>
-              <a:srgbClr val="D8DEE6"/>
+              <a:srgbClr val="1E2329"/>
             </a:solidFill>
             <a:prstDash val="solid"/>
           </a:ln>
@@ -22153,8 +22365,8 @@
         </p:nvSpPr>
         <p:spPr>
           <a:xfrm>
-            <a:off x="6473952" y="2743200"/>
-            <a:ext cx="4937760" cy="411480"/>
+            <a:off x="6903720" y="1828800"/>
+            <a:ext cx="4602175" cy="3063240"/>
           </a:xfrm>
           <a:prstGeom prst="rect">
             <a:avLst/>
@@ -22163,24 +22375,205 @@
           <a:ln/>
         </p:spPr>
         <p:txBody>
-          <a:bodyPr wrap="square" lIns="0" tIns="0" rIns="0" bIns="0" rtlCol="0" anchor="ctr"/>
+          <a:bodyPr wrap="square" lIns="0" tIns="0" rIns="0" bIns="0" rtlCol="0" anchor="t"/>
           <a:lstStyle/>
           <a:p>
             <a:pPr indent="0" marL="0">
-              <a:buNone/>
-            </a:pPr>
-            <a:r>
-              <a:rPr lang="en-US" sz="1800" b="1" dirty="0">
-                <a:solidFill>
-                  <a:srgbClr val="1F2328"/>
-                </a:solidFill>
-                <a:latin typeface="Arial" pitchFamily="34" charset="0"/>
-                <a:ea typeface="Arial" pitchFamily="34" charset="-122"/>
-                <a:cs typeface="Arial" pitchFamily="34" charset="-120"/>
-              </a:rPr>
-              <a:t>v = its write vector</a:t>
-            </a:r>
-            <a:endParaRPr lang="en-US" sz="1800" dirty="0"/>
+              <a:spcAft>
+                <a:spcPts val="300"/>
+              </a:spcAft>
+              <a:buNone/>
+            </a:pPr>
+            <a:r>
+              <a:rPr lang="en-US" sz="1200" dirty="0">
+                <a:solidFill>
+                  <a:srgbClr val="E6EDF3"/>
+                </a:solidFill>
+                <a:latin typeface="Courier New" pitchFamily="34" charset="0"/>
+                <a:ea typeface="Courier New" pitchFamily="34" charset="-122"/>
+                <a:cs typeface="Courier New" pitchFamily="34" charset="-120"/>
+              </a:rPr>
+              <a:t>mlp = model.model.layers[14].mlp</a:t>
+            </a:r>
+            <a:endParaRPr lang="en-US" sz="1200" dirty="0"/>
+          </a:p>
+          <a:p>
+            <a:pPr indent="0" marL="0">
+              <a:spcAft>
+                <a:spcPts val="300"/>
+              </a:spcAft>
+              <a:buNone/>
+            </a:pPr>
+            <a:endParaRPr lang="en-US" sz="1200" dirty="0"/>
+          </a:p>
+          <a:p>
+            <a:pPr indent="0" marL="0">
+              <a:spcAft>
+                <a:spcPts val="300"/>
+              </a:spcAft>
+              <a:buNone/>
+            </a:pPr>
+            <a:r>
+              <a:rPr lang="en-US" sz="1200" dirty="0">
+                <a:solidFill>
+                  <a:srgbClr val="8B98A8"/>
+                </a:solidFill>
+                <a:latin typeface="Courier New" pitchFamily="34" charset="0"/>
+                <a:ea typeface="Courier New" pitchFamily="34" charset="-122"/>
+                <a:cs typeface="Courier New" pitchFamily="34" charset="-120"/>
+              </a:rPr>
+              <a:t># read or pin the neurons: hook the</a:t>
+            </a:r>
+            <a:endParaRPr lang="en-US" sz="1200" dirty="0"/>
+          </a:p>
+          <a:p>
+            <a:pPr indent="0" marL="0">
+              <a:spcAft>
+                <a:spcPts val="300"/>
+              </a:spcAft>
+              <a:buNone/>
+            </a:pPr>
+            <a:r>
+              <a:rPr lang="en-US" sz="1200" dirty="0">
+                <a:solidFill>
+                  <a:srgbClr val="8B98A8"/>
+                </a:solidFill>
+                <a:latin typeface="Courier New" pitchFamily="34" charset="0"/>
+                <a:ea typeface="Courier New" pitchFamily="34" charset="-122"/>
+                <a:cs typeface="Courier New" pitchFamily="34" charset="-120"/>
+              </a:rPr>
+              <a:t># input of down_proj (= h)</a:t>
+            </a:r>
+            <a:endParaRPr lang="en-US" sz="1200" dirty="0"/>
+          </a:p>
+          <a:p>
+            <a:pPr indent="0" marL="0">
+              <a:spcAft>
+                <a:spcPts val="300"/>
+              </a:spcAft>
+              <a:buNone/>
+            </a:pPr>
+            <a:r>
+              <a:rPr lang="en-US" sz="1200" dirty="0">
+                <a:solidFill>
+                  <a:srgbClr val="E6EDF3"/>
+                </a:solidFill>
+                <a:latin typeface="Courier New" pitchFamily="34" charset="0"/>
+                <a:ea typeface="Courier New" pitchFamily="34" charset="-122"/>
+                <a:cs typeface="Courier New" pitchFamily="34" charset="-120"/>
+              </a:rPr>
+              <a:t>mlp.down_proj.register_forward_pre_hook(</a:t>
+            </a:r>
+            <a:endParaRPr lang="en-US" sz="1200" dirty="0"/>
+          </a:p>
+          <a:p>
+            <a:pPr indent="0" marL="0">
+              <a:spcAft>
+                <a:spcPts val="300"/>
+              </a:spcAft>
+              <a:buNone/>
+            </a:pPr>
+            <a:r>
+              <a:rPr lang="en-US" sz="1200" b="1" dirty="0">
+                <a:solidFill>
+                  <a:srgbClr val="F2A97F"/>
+                </a:solidFill>
+                <a:latin typeface="Courier New" pitchFamily="34" charset="0"/>
+                <a:ea typeface="Courier New" pitchFamily="34" charset="-122"/>
+                <a:cs typeface="Courier New" pitchFamily="34" charset="-120"/>
+              </a:rPr>
+              <a:t>    hook)   # e.g. h[..., 7924] = 20</a:t>
+            </a:r>
+            <a:endParaRPr lang="en-US" sz="1200" dirty="0"/>
+          </a:p>
+          <a:p>
+            <a:pPr indent="0" marL="0">
+              <a:spcAft>
+                <a:spcPts val="300"/>
+              </a:spcAft>
+              <a:buNone/>
+            </a:pPr>
+            <a:endParaRPr lang="en-US" sz="1200" dirty="0"/>
+          </a:p>
+          <a:p>
+            <a:pPr indent="0" marL="0">
+              <a:spcAft>
+                <a:spcPts val="300"/>
+              </a:spcAft>
+              <a:buNone/>
+            </a:pPr>
+            <a:r>
+              <a:rPr lang="en-US" sz="1200" dirty="0">
+                <a:solidFill>
+                  <a:srgbClr val="8B98A8"/>
+                </a:solidFill>
+                <a:latin typeface="Courier New" pitchFamily="34" charset="0"/>
+                <a:ea typeface="Courier New" pitchFamily="34" charset="-122"/>
+                <a:cs typeface="Courier New" pitchFamily="34" charset="-120"/>
+              </a:rPr>
+              <a:t># neuron 7924's write vector:</a:t>
+            </a:r>
+            <a:endParaRPr lang="en-US" sz="1200" dirty="0"/>
+          </a:p>
+          <a:p>
+            <a:pPr indent="0" marL="0">
+              <a:spcAft>
+                <a:spcPts val="300"/>
+              </a:spcAft>
+              <a:buNone/>
+            </a:pPr>
+            <a:r>
+              <a:rPr lang="en-US" sz="1200" dirty="0">
+                <a:solidFill>
+                  <a:srgbClr val="8B98A8"/>
+                </a:solidFill>
+                <a:latin typeface="Courier New" pitchFamily="34" charset="0"/>
+                <a:ea typeface="Courier New" pitchFamily="34" charset="-122"/>
+                <a:cs typeface="Courier New" pitchFamily="34" charset="-120"/>
+              </a:rPr>
+              <a:t># column 7924 of down_proj's weight</a:t>
+            </a:r>
+            <a:endParaRPr lang="en-US" sz="1200" dirty="0"/>
+          </a:p>
+          <a:p>
+            <a:pPr indent="0" marL="0">
+              <a:spcAft>
+                <a:spcPts val="300"/>
+              </a:spcAft>
+              <a:buNone/>
+            </a:pPr>
+            <a:r>
+              <a:rPr lang="en-US" sz="1200" b="1" dirty="0">
+                <a:solidFill>
+                  <a:srgbClr val="F2A97F"/>
+                </a:solidFill>
+                <a:latin typeface="Courier New" pitchFamily="34" charset="0"/>
+                <a:ea typeface="Courier New" pitchFamily="34" charset="-122"/>
+                <a:cs typeface="Courier New" pitchFamily="34" charset="-120"/>
+              </a:rPr>
+              <a:t>v = mlp.down_proj.weight[:, 7924]</a:t>
+            </a:r>
+            <a:endParaRPr lang="en-US" sz="1200" dirty="0"/>
+          </a:p>
+          <a:p>
+            <a:pPr indent="0" marL="0">
+              <a:spcAft>
+                <a:spcPts val="300"/>
+              </a:spcAft>
+              <a:buNone/>
+            </a:pPr>
+            <a:r>
+              <a:rPr lang="en-US" sz="1200" dirty="0">
+                <a:solidFill>
+                  <a:srgbClr val="8B98A8"/>
+                </a:solidFill>
+                <a:latin typeface="Courier New" pitchFamily="34" charset="0"/>
+                <a:ea typeface="Courier New" pitchFamily="34" charset="-122"/>
+                <a:cs typeface="Courier New" pitchFamily="34" charset="-120"/>
+              </a:rPr>
+              <a:t>#  → 4,096 fixed numbers</a:t>
+            </a:r>
+            <a:endParaRPr lang="en-US" sz="1200" dirty="0"/>
           </a:p>
         </p:txBody>
       </p:sp>
@@ -22192,8 +22585,8 @@
         </p:nvSpPr>
         <p:spPr>
           <a:xfrm>
-            <a:off x="6473952" y="3200400"/>
-            <a:ext cx="4937760" cy="1097280"/>
+            <a:off x="548640" y="5120640"/>
+            <a:ext cx="11094415" cy="1005840"/>
           </a:xfrm>
           <a:prstGeom prst="rect">
             <a:avLst/>
@@ -22209,6 +22602,20 @@
               <a:buNone/>
             </a:pPr>
             <a:r>
+              <a:rPr lang="en-US" sz="1500" b="1" dirty="0">
+                <a:solidFill>
+                  <a:srgbClr val="1F2328"/>
+                </a:solidFill>
+                <a:latin typeface="Arial" pitchFamily="34" charset="0"/>
+                <a:ea typeface="Arial" pitchFamily="34" charset="-122"/>
+                <a:cs typeface="Arial" pitchFamily="34" charset="-120"/>
+              </a:rPr>
+              <a:t>down_proj(h) adds up h[i] × column i over all 12,288 neurons. </a:t>
+            </a:r>
+            <a:pPr indent="0" marL="0">
+              <a:buNone/>
+            </a:pPr>
+            <a:r>
               <a:rPr lang="en-US" sz="1500" dirty="0">
                 <a:solidFill>
                   <a:srgbClr val="1F2328"/>
@@ -22217,62 +22624,9 @@
                 <a:ea typeface="Arial" pitchFamily="34" charset="-122"/>
                 <a:cs typeface="Arial" pitchFamily="34" charset="-120"/>
               </a:rPr>
-              <a:t>A fixed list of 4,096 numbers, learned in training (one column of the “shrink” matrix, down_proj). Never changes.</a:t>
+              <a:t>So when neuron 7924 fires, it adds h[7924] × its own fixed column v to the residual stream: its write vector, scaled by how strongly it fires. The refusal direction lives in the same residual stream, so we can ask whether v points the same way.</a:t>
             </a:r>
             <a:endParaRPr lang="en-US" sz="1500" dirty="0"/>
-          </a:p>
-        </p:txBody>
-      </p:sp>
-      <p:sp>
-        <p:nvSpPr>
-          <p:cNvPr id="13" name="Text 10"/>
-          <p:cNvSpPr/>
-          <p:nvPr/>
-        </p:nvSpPr>
-        <p:spPr>
-          <a:xfrm>
-            <a:off x="548640" y="4663440"/>
-            <a:ext cx="11094415" cy="914400"/>
-          </a:xfrm>
-          <a:prstGeom prst="rect">
-            <a:avLst/>
-          </a:prstGeom>
-          <a:noFill/>
-          <a:ln/>
-        </p:spPr>
-        <p:txBody>
-          <a:bodyPr wrap="square" lIns="0" tIns="0" rIns="0" bIns="0" rtlCol="0" anchor="t"/>
-          <a:lstStyle/>
-          <a:p>
-            <a:pPr indent="0" marL="0">
-              <a:buNone/>
-            </a:pPr>
-            <a:r>
-              <a:rPr lang="en-US" sz="1700" b="1" dirty="0">
-                <a:solidFill>
-                  <a:srgbClr val="1F2328"/>
-                </a:solidFill>
-                <a:latin typeface="Arial" pitchFamily="34" charset="0"/>
-                <a:ea typeface="Arial" pitchFamily="34" charset="-122"/>
-                <a:cs typeface="Arial" pitchFamily="34" charset="-120"/>
-              </a:rPr>
-              <a:t>So when a neuron fires, it adds its own fixed arrow v to the residual stream, scaled by how strongly it fires. </a:t>
-            </a:r>
-            <a:pPr indent="0" marL="0">
-              <a:buNone/>
-            </a:pPr>
-            <a:r>
-              <a:rPr lang="en-US" sz="1700" dirty="0">
-                <a:solidFill>
-                  <a:srgbClr val="1F2328"/>
-                </a:solidFill>
-                <a:latin typeface="Arial" pitchFamily="34" charset="0"/>
-                <a:ea typeface="Arial" pitchFamily="34" charset="-122"/>
-                <a:cs typeface="Arial" pitchFamily="34" charset="-120"/>
-              </a:rPr>
-              <a:t>Since the refusal direction also lives in the residual stream, we can ask: does a neuron's arrow point the same way as the refusal direction?</a:t>
-            </a:r>
-            <a:endParaRPr lang="en-US" sz="1700" dirty="0"/>
           </a:p>
         </p:txBody>
       </p:sp>

</xml_diff>